<commit_message>
feat(box): 20a regeneration inputs - Midland card ledger, D136, owner WCD
Michael's 50 card verdicts (36 agree / 14 reject) swap the five carded classes
into a Midland ledger (D134 B): WCA->WCB_1 0.70, WCB_2->WCB_1 1.00,
WCB_2->WCC 0.70, WCC->WCB_2 0.70 accepted; WCB_1->WCA 0.50 rejected.
D136 applied in the family build (north WCB_2 at WCB_1 depth -> WCB_1) and
the WCB_2 extent clip; owner bench file (6 OTHER-tagged wells -> WCD);
edited-deck ingest takes --basin and counts D117 undrilled outside the Delaware.
Deck with Michael's WCC / WCD loops.

Co-Authored-By: Claude Opus 5.5 <noreply@anthropic.com>
</commit_message>
<xml_diff>
--- a/docs/box/step20a-2026-10-26/extents/midland_wolfcamp_extents_2026-10-26.pptx
+++ b/docs/box/step20a-2026-10-26/extents/midland_wolfcamp_extents_2026-10-26.pptx
@@ -5,13 +5,13 @@
     <p:sldMasterId id="2147483648" r:id="rId1"/>
   </p:sldMasterIdLst>
   <p:sldIdLst>
-    <p:sldId id="256" r:id="rId7"/>
-    <p:sldId id="257" r:id="rId8"/>
-    <p:sldId id="258" r:id="rId9"/>
-    <p:sldId id="259" r:id="rId10"/>
-    <p:sldId id="260" r:id="rId11"/>
+    <p:sldId id="256" r:id="rId2"/>
+    <p:sldId id="257" r:id="rId3"/>
+    <p:sldId id="258" r:id="rId4"/>
+    <p:sldId id="259" r:id="rId5"/>
+    <p:sldId id="260" r:id="rId6"/>
   </p:sldIdLst>
-  <p:sldSz cx="12192000" cy="6858000" type="screen4x3"/>
+  <p:sldSz cx="12192000" cy="6858000"/>
   <p:notesSz cx="6858000" cy="9144000"/>
   <p:defaultTextStyle>
     <a:defPPr>
@@ -108,7 +108,79 @@
       </a:defRPr>
     </a:lvl9pPr>
   </p:defaultTextStyle>
+  <p:extLst>
+    <p:ext uri="{EFAFB233-063F-42B5-8137-9DF3F51BA10A}">
+      <p15:sldGuideLst xmlns:p15="http://schemas.microsoft.com/office/powerpoint/2012/main">
+        <p15:guide id="1" orient="horz" pos="2160">
+          <p15:clr>
+            <a:srgbClr val="A4A3A4"/>
+          </p15:clr>
+        </p15:guide>
+        <p15:guide id="2" pos="2880">
+          <p15:clr>
+            <a:srgbClr val="A4A3A4"/>
+          </p15:clr>
+        </p15:guide>
+      </p15:sldGuideLst>
+    </p:ext>
+  </p:extLst>
 </p:presentation>
+</file>
+
+<file path=ppt/ink/ink1.xml><?xml version="1.0" encoding="utf-8"?>
+<inkml:ink xmlns:inkml="http://www.w3.org/2003/InkML">
+  <inkml:definitions>
+    <inkml:context xml:id="ctx0">
+      <inkml:inkSource xml:id="inkSrc0">
+        <inkml:traceFormat>
+          <inkml:channel name="X" type="integer" min="-2.14748E9" max="2.14748E9" units="cm"/>
+          <inkml:channel name="Y" type="integer" min="-2.14748E9" max="2.14748E9" units="cm"/>
+          <inkml:channel name="F" type="integer" max="32767" units="dev"/>
+        </inkml:traceFormat>
+        <inkml:channelProperties>
+          <inkml:channelProperty channel="X" name="resolution" value="1000" units="1/cm"/>
+          <inkml:channelProperty channel="Y" name="resolution" value="1000" units="1/cm"/>
+          <inkml:channelProperty channel="F" name="resolution" value="0" units="1/dev"/>
+        </inkml:channelProperties>
+      </inkml:inkSource>
+      <inkml:timestamp xml:id="ts0" timeString="2026-10-26T23:40:24.911"/>
+    </inkml:context>
+    <inkml:brush xml:id="br0">
+      <inkml:brushProperty name="width" value="0.035" units="cm"/>
+      <inkml:brushProperty name="height" value="0.035" units="cm"/>
+      <inkml:brushProperty name="color" value="#E71224"/>
+    </inkml:brush>
+  </inkml:definitions>
+  <inkml:trace contextRef="#ctx0" brushRef="#br0">50 683 24575,'2'94'0,"-5"104"0,-8-124 0,-2 21 0,1-5 0,0 3 0,12-84 0,0 1 0,0-1 0,1 0 0,0 1 0,1-1 0,0 0 0,0 0 0,1 0 0,0-1 0,1 1 0,0-1 0,0 1 0,1-1 0,0 0 0,0-1 0,1 1 0,0-1 0,14 12 0,-14-12 0,9 7 0,-1 2 0,-1-1 0,15 23 0,-24-31 0,0 1 0,-1-1 0,0 1 0,0 1 0,0-1 0,-1 0 0,0 0 0,-1 1 0,0-1 0,0 17 0,-1-11 0,0 0 0,2 0 0,-1 0 0,2 0 0,-1 0 0,2-1 0,0 1 0,1-1 0,0 0 0,14 24 0,58 103 0,-72-129 0,-1 0 0,0-1 0,-1 2 0,0-1 0,-1 0 0,0 0 0,1 18 0,4 23 0,1 1 0,-6-39 0,0 0 0,0 0 0,2 0 0,7 22 0,-1-14 0,-1-1 0,-1 1 0,-1 1 0,-1 0 0,-1-1 0,-1 2 0,-1-1 0,0 29 0,-3 58 0,-4 121 0,1-208 0,-1-1 0,-13 40 0,-1 4 0,-51 165 0,17-66 0,35-98 0,4 1 0,2 0 0,4 0 0,1 108 0,-6 30 0,-1 2 0,12 6 0,4 167 0,0-354 0,2-1 0,1 0 0,1 0 0,16 39 0,-4-12 0,-12-33 0,1-1 0,1 0 0,1-1 0,1 0 0,0-1 0,1 0 0,17 18 0,7 3 0,67 55 0,-91-81 0,-1 0 0,-1 0 0,0 1 0,0 0 0,-2 1 0,0 0 0,0 1 0,-1-1 0,-1 1 0,0 1 0,-2-1 0,1 1 0,-2 0 0,3 25 0,-2-20 0,1-2 0,0 1 0,15 33 0,-12-35 0,-2 0 0,0 0 0,-1 1 0,5 32 0,-7-16 0,-4-25 0,1 0 0,1-1 0,0 1 0,0-1 0,1 1 0,0-1 0,0 1 0,1-1 0,0 0 0,1 0 0,0 0 0,1-1 0,-1 1 0,2-1 0,7 10 0,-5-9 0,-1 0 0,0 0 0,-1 1 0,0 0 0,0 0 0,-1 1 0,5 14 0,19 82 0,-11-31 0,-1-7 0,-12-45 0,1-1 0,1 0 0,1 0 0,13 26 0,-9-25 0,-2 1 0,-1 0 0,7 33 0,-12-39 0,1 1 0,1-1 0,1 0 0,1 0 0,1-1 0,21 34 0,79 76 0,-96-114 0,26 24 0,-26-26 0,0 1 0,18 23 0,34 38 0,-49-57 0,0 1 0,0 0 0,17 29 0,-12-15 0,42 49 0,12 18 0,-68-85 0,0 0 0,-1 1 0,-1-1 0,-1 1 0,0 0 0,0 1 0,-2-1 0,2 27 0,-3-26 0,1 0 0,0-1 0,1 1 0,0-1 0,1 0 0,1 0 0,1 0 0,14 27 0,-1-16 0,1-1 0,47 44 0,-45-47 0,0 0 0,-1 2 0,21 31 0,-27-33 0,2 0 0,0-1 0,1 0 0,39 33 0,-50-47 0,1 1 0,-2 0 0,1 0 0,-1 1 0,0 0 0,-1 0 0,0 0 0,-1 0 0,1 1 0,-2 0 0,0 0 0,3 13 0,9 24 0,-3-23 0,0 0 0,2 0 0,0-2 0,2 0 0,0-1 0,37 37 0,22 29 0,-11-8 0,4-2 0,92 80 0,-9-32 0,-113-93 0,-29-26 0,-1 1 0,0 0 0,-1 0 0,0 0 0,0 1 0,0 0 0,-1 0 0,7 12 0,-4-6 0,0 0 0,2-1 0,0 0 0,0-1 0,1 0 0,0-1 0,17 12 0,43 42 0,-55-46 0,0-2 0,1 0 0,35 26 0,-44-37 0,0-1 0,0 0 0,1 0 0,0-1 0,0 0 0,0-1 0,0 0 0,0 0 0,0-1 0,1-1 0,18 2 0,274-32 0,-191 15 0,-67 8 0,-1-2 0,0-1 0,-1-3 0,0-1 0,-1-2 0,0-2 0,52-30 0,-76 38 0,-1 2 0,1 0 0,0 1 0,32-6 0,32-11 0,-28 4 0,0 2 0,1 3 0,1 2 0,0 3 0,1 2 0,-1 2 0,1 3 0,70 6 0,-111 0 0,0-1 0,0 2 0,0 0 0,0 1 0,-1 1 0,0 0 0,0 1 0,0 1 0,13 10 0,-5-4 0,0-1 0,33 14 0,-29-18 0,17 9 0,1-2 0,1-3 0,76 15 0,-103-24 0,0 1 0,0 1 0,-1 1 0,0 0 0,0 1 0,-1 1 0,26 19 0,13 7 0,237 140 0,-254-150 0,-1 2 0,34 33 0,5 4 0,-18-16 0,-29-24 0,51 35 0,-14-15 0,-41-26 0,1-2 0,0-1 0,31 13 0,-21-12 0,1-2 0,1-2 0,0-1 0,1-3 0,0 0 0,0-3 0,44 2 0,-55-7 0,51 9 0,-49-5 0,46 2 0,39-5 0,266-5 0,-351 1 0,0-1 0,0-1 0,0-2 0,53-16 0,-70 17 0,0-1 0,-1 0 0,0-1 0,0-1 0,0 0 0,-1-1 0,-1 0 0,1 0 0,-1-2 0,-1 1 0,0-1 0,11-16 0,26-38 0,53-82 0,-87 125 0,-1-2 0,-1 0 0,-1 0 0,12-50 0,-12 19 0,-4-1 0,-1 1 0,-5-81 0,3-39 0,-1 164 0,0 0 0,1 0 0,0 0 0,1 1 0,0-1 0,0 1 0,10-15 0,-7 11 0,0 0 0,10-29 0,-6-11 0,-3 0 0,-1 0 0,-3 0 0,-5-80 0,1 77 0,-2 30 0,-1 1 0,-1 0 0,-14-46 0,-3-19 0,12 58 0,-1 1 0,-2 0 0,-1 1 0,-2 0 0,0 1 0,-21-28 0,-2-8 0,11 15 0,9 16 0,-1 0 0,-2 2 0,-47-60 0,52 77 0,1-2 0,1 0 0,1 0 0,1-1 0,0-1 0,1 0 0,-15-43 0,12 32 0,0 1 0,-3 0 0,0 1 0,-2 1 0,-1 1 0,-45-48 0,50 58 0,7 6 0,0 0 0,1-1 0,0 0 0,1 0 0,-7-20 0,7 16 0,-2 1 0,-14-26 0,-3 0 0,-35-80 0,38 74 0,-33-56 0,-15 6 0,-11-19 0,74 103 0,0-1 0,2 0 0,-6-19 0,7 18 0,-2 1 0,1-1 0,-9-13 0,-5 0 0,-2 1 0,-1 1 0,-1 1 0,-1 1 0,-1 1 0,-36-25 0,-55-53 0,52 41 0,-2 2 0,-3 4 0,-86-53 0,65 45 0,-117-105 0,179 139 0,1-1 0,2-1 0,-39-60 0,38 52 0,-1 1 0,-42-44 0,52 61 0,0-1 0,1-1 0,-24-42 0,25 36 0,-3 1 0,-22-27 0,-17-5 0,45 49 0,1-1 0,0 0 0,0-1 0,1 0 0,1 0 0,0-1 0,1-1 0,0 1 0,-6-17 0,-49-169 0,36 135 0,21 52 0,0 0 0,1-1 0,0 0 0,1 0 0,1 0 0,0-1 0,-1-13 0,3-263 0,3 134 0,-2 139 0,1 0 0,1 0 0,0 1 0,1-1 0,1 1 0,0-1 0,1 1 0,1 1 0,1-1 0,0 1 0,13-20 0,-8 18 0,0 1 0,2 0 0,0 1 0,0 0 0,2 2 0,-1-1 0,2 2 0,31-19 0,-38 25 0,-1 1 0,0-2 0,0 1 0,-1-1 0,1 0 0,-2-1 0,1 0 0,-1 0 0,0-1 0,-1 1 0,0-1 0,0-1 0,-1 1 0,0-1 0,5-16 0,3-1 0,1 0 0,1 0 0,20-24 0,-18 28 0,-2 0 0,-1-2 0,21-45 0,-25 42 0,2 1 0,0 0 0,2 0 0,2 1 0,0 1 0,1 1 0,40-44 0,-42 52 0,-1-1 0,-1-1 0,-1 0 0,0 0 0,-1-1 0,12-31 0,37-129 0,-26 68 0,57-186 0,-50 198 0,-21 55 0,15-49 0,-5-38 0,-12 45 0,5 12 0,-17 58 0,0-1 0,-1 0 0,-1 0 0,0 0 0,1-20 0,-4-240 0,-3 130 0,1 135 0,0-1 0,0 1 0,-2-1 0,1 1 0,-1 0 0,-1-1 0,-1 2 0,1-1 0,-9-14 0,-8-10 0,-40-50 0,40 59 0,1-2 0,-27-50 0,40 66 0,0 0 0,-1 0 0,-1 1 0,0 0 0,-1 1 0,0 0 0,-1 0 0,-18-14 0,10 11 0,-1 1 0,0 0 0,0 2 0,-40-16 0,41 20 0,-1 2 0,0 0 0,0 1 0,0 1 0,-22 0 0,-106 4 0,73 1 0,-30-3 0,-92 4 0,167 2 0,0 1 0,1 1 0,-1 2 0,1 1 0,-52 26 0,38-17 0,-61 19 0,59-27 0,0-2 0,-88 7 0,-95-13 0,144-4 0,47 3 0,-49 9 0,47-6 0,-42 2 0,-22-5 0,-442-5 0,522-1 0,0 0 0,1-1 0,0-1 0,0-2 0,0 0 0,1-1 0,-35-21 0,-43-17 0,-104-24 0,171 63 0,0 1 0,-1 1 0,0 2 0,-52 1 0,38 4 0,17 1 0,0-2 0,-59-7 0,80 6 0,-1-1 0,1-1 0,-1 0 0,1 0 0,0-1 0,1 0 0,-1-1 0,1 1 0,-1-2 0,1 1 0,1-1 0,-1 0 0,-8-11 0,-4-9 0,1-1 0,1-1 0,2 0 0,1-2 0,1 1 0,-11-36 0,18 45 0,3 6 0,-1 0 0,0 1 0,-1-1 0,0 1 0,-1 0 0,-1 1 0,0-1 0,0 1 0,-1 1 0,-1 0 0,0 0 0,-12-9 0,-231-154 0,243 168 0,-1 1 0,0 1 0,0 0 0,-1 1 0,1 0 0,-1 0 0,0 1 0,-15 0 0,-102 3 0,68 1 0,-98-2 0,-104 2 0,222 2 0,0 1 0,0 2 0,1 2 0,-50 17 0,-154 71 0,174-67 0,45-18 0,0 2 0,1 1 0,1 0 0,-27 24 0,20-15 0,-47 28 0,60-44 0,1-1 0,-2-1 0,1 0 0,-1-1 0,-18 2 0,13-2 0,0 1 0,-32 12 0,43-14 0,0 0 0,0-1 0,0 0 0,-15 0 0,16-2 0,0 1 0,0 0 0,0 1 0,-19 7 0,26-8 0,1 0 0,-1 0 0,1 0 0,0 0 0,0 1 0,0-1 0,0 1 0,0 0 0,0 0 0,1 0 0,-1 0 0,1 1 0,0-1 0,0 1 0,1-1 0,-1 1 0,-2 7 0,-28 121 0,10-31 0,15-83-227,0-1-1,-1 1 1,-1-1-1,-1-1 1,-14 21-1,13-23-6598</inkml:trace>
+</inkml:ink>
+</file>
+
+<file path=ppt/ink/ink2.xml><?xml version="1.0" encoding="utf-8"?>
+<inkml:ink xmlns:inkml="http://www.w3.org/2003/InkML">
+  <inkml:definitions>
+    <inkml:context xml:id="ctx0">
+      <inkml:inkSource xml:id="inkSrc0">
+        <inkml:traceFormat>
+          <inkml:channel name="X" type="integer" min="-2.14748E9" max="2.14748E9" units="cm"/>
+          <inkml:channel name="Y" type="integer" min="-2.14748E9" max="2.14748E9" units="cm"/>
+          <inkml:channel name="F" type="integer" max="32767" units="dev"/>
+        </inkml:traceFormat>
+        <inkml:channelProperties>
+          <inkml:channelProperty channel="X" name="resolution" value="1000" units="1/cm"/>
+          <inkml:channelProperty channel="Y" name="resolution" value="1000" units="1/cm"/>
+          <inkml:channelProperty channel="F" name="resolution" value="0" units="1/dev"/>
+        </inkml:channelProperties>
+      </inkml:inkSource>
+      <inkml:timestamp xml:id="ts0" timeString="2026-10-26T23:40:52.631"/>
+    </inkml:context>
+    <inkml:brush xml:id="br0">
+      <inkml:brushProperty name="width" value="0.035" units="cm"/>
+      <inkml:brushProperty name="height" value="0.035" units="cm"/>
+      <inkml:brushProperty name="color" value="#E71224"/>
+    </inkml:brush>
+  </inkml:definitions>
+  <inkml:trace contextRef="#ctx0" brushRef="#br0">146 4337 24575,'1'13'0,"1"0"0,0-1 0,1 0 0,0 1 0,1-1 0,0 0 0,1-1 0,1 1 0,-1-1 0,9 11 0,-4-4 0,0 0 0,12 36 0,9 78 0,-30-126 0,1 0 0,1 0 0,-1 0 0,1 0 0,0-1 0,1 1 0,-1-1 0,1 0 0,0 0 0,6 6 0,-5-5 0,1 1 0,-1 0 0,0 0 0,0 0 0,5 13 0,41 148 0,-25-103 0,67 117 0,-54-111 0,-7 5 0,-27-61 0,1 0 0,0 0 0,0-1 0,2 0 0,16 24 0,-12-22 0,-1 1 0,-1 0 0,-1 1 0,0 0 0,-1 0 0,-1 1 0,7 31 0,-13-47 0,4 10 0,2 0 0,-1 0 0,2 0 0,-1-1 0,2 0 0,-1-1 0,2 0 0,-1 0 0,2-1 0,13 11 0,-9-8 0,-1 0 0,-1 2 0,0-1 0,19 29 0,-23-23 0,0 0 0,0 0 0,6 27 0,12 30 0,-20-63 0,1-1 0,16 23 0,7 9 0,-25-36 0,1 0 0,0 0 0,0 0 0,1-1 0,0-1 0,1 1 0,9 6 0,-9-8 0,-1 0 0,0 1 0,0 0 0,0 1 0,-1-1 0,-1 1 0,1 1 0,8 15 0,9 26 0,37 67 0,-51-102 0,1-1 0,1-1 0,26 24 0,-23-24 0,-1 1 0,24 30 0,-20-17 0,5 7 0,1-1 0,57 59 0,8 17 0,-61-79 0,24 34 0,-28-33 0,34 33 0,-48-53 0,0 0 0,-1 1 0,0 0 0,-1 0 0,0 1 0,-1 0 0,-1 0 0,6 18 0,4 17 0,9 54 0,-14-54 0,40 121 0,-46-147 0,-2 1 0,0 0 0,-1 0 0,-2 42 0,-1-38 0,1 0 0,8 53 0,37 113 0,2-47 0,-28-59 0,-13-54 0,14 45 0,-13-52 0,-1 0 0,5 52 0,4 15 0,-12-70 0,0-1 0,0 25 0,-4-34 0,1-1 0,1 1 0,0-1 0,1 1 0,1-1 0,-1 1 0,2-1 0,0 0 0,0-1 0,11 20 0,17 27 0,-26-44 0,2 0 0,-1-1 0,2 0 0,16 21 0,59 66 0,-56-64 0,1-1 0,2-2 0,39 33 0,-60-58 0,-1-1 0,0 1 0,0 1 0,-1-1 0,0 1 0,-1 1 0,0 0 0,0 0 0,-1 0 0,0 1 0,6 15 0,-4-9 0,2-1 0,0-1 0,1 1 0,1-1 0,0-1 0,1-1 0,0 1 0,26 18 0,6 9 0,-36-32 0,0 0 0,1 0 0,0-1 0,0 0 0,0-1 0,1 0 0,0 0 0,1-1 0,0-1 0,-1 0 0,2-1 0,-1 0 0,0 0 0,1-2 0,0 1 0,-1-2 0,20 1 0,61-2 0,220-5 0,-285 1 0,1-1 0,-1-2 0,-1-1 0,1-1 0,30-15 0,20-5 0,-57 21 0,1 1 0,0 1 0,0 1 0,1 1 0,41-2 0,-59 7 0,1-2 0,-1 1 0,0-1 0,1 1 0,-1-1 0,0-1 0,0 1 0,0-1 0,0 0 0,0 0 0,0 0 0,-1-1 0,1 0 0,-1 0 0,6-4 0,-8 4 0,0 1 0,0-1 0,0 0 0,0 0 0,0 1 0,-1-1 0,0 0 0,1 0 0,-1-1 0,0 1 0,-1 0 0,1 0 0,0 0 0,-1-1 0,0 1 0,0 0 0,0 0 0,0-1 0,0 1 0,-1 0 0,1 0 0,-1-1 0,0 1 0,0 0 0,0 0 0,-2-4 0,-25-52 0,20 46 0,2 0 0,0-1 0,-6-21 0,10 29 0,1-1 0,0 0 0,0 1 0,1-1 0,0 0 0,0 0 0,1 1 0,0-1 0,0 0 0,0 1 0,3-8 0,4-6 0,0 1 0,1 0 0,1 0 0,1 1 0,1 1 0,20-24 0,0-2 0,-25 32 0,0 0 0,0-1 0,-1 0 0,-1 0 0,0 0 0,0-1 0,-1 0 0,-1 0 0,2-16 0,-1-8 0,-3-72 0,0-17 0,11 61 0,0-14 0,-11 27 0,12-149 0,-9 172 0,1-5 0,12-48 0,-13 69 0,0 1 0,1-1 0,1 2 0,0-1 0,0 0 0,1 1 0,11-13 0,-8 12 0,0 0 0,-1-1 0,-1 0 0,0-1 0,0 1 0,-2-2 0,0 1 0,0-1 0,4-18 0,0 1 0,2 2 0,1-1 0,1 2 0,2 0 0,26-37 0,14-26 0,-37 63 0,0 1 0,2 1 0,42-44 0,25-29 0,-79 85 0,1-1 0,-2 0 0,9-22 0,-13 27 0,0 1 0,0 0 0,1 0 0,0 1 0,1 0 0,0 0 0,0 0 0,1 0 0,0 1 0,1 0 0,14-11 0,22-11 0,-2-1 0,0-2 0,-2-2 0,-2-2 0,-1-1 0,31-43 0,-24 26 0,-24 31 0,32-50 0,-46 65 0,-1 0 0,-1 0 0,0-1 0,0 0 0,-1 0 0,-1 0 0,1 0 0,-1 0 0,0-18 0,-1 1 0,-1 0 0,-1 0 0,-2 1 0,-7-36 0,7 51 0,-1-1 0,0 1 0,-1 0 0,0 0 0,0 1 0,-1 0 0,0 0 0,-1 0 0,0 1 0,-1-1 0,0 2 0,-11-11 0,-7-4 0,2-3 0,1 0 0,1-1 0,-31-50 0,15 31 0,31 39 0,1 0 0,0 0 0,0-1 0,1 1 0,-1-1 0,2 0 0,-6-13 0,-8-28 0,4 8 0,-2 1 0,-1 1 0,-42-71 0,43 89 0,2-2 0,1 0 0,1-1 0,0 0 0,2-1 0,1 0 0,-7-34 0,-7-65 0,20 109 0,0 1 0,-1 0 0,-9-21 0,8 22 0,0 0 0,1 0 0,0-1 0,-3-24 0,6-202 0,3 118 0,0 88 0,2 1 0,1 1 0,2-1 0,1 1 0,1 0 0,2 1 0,2 0 0,24-45 0,-32 66 0,2 0 0,-1 1 0,1 0 0,1 0 0,-1 1 0,1 0 0,1 0 0,17-12 0,6 0 0,46-23 0,-12 8 0,-55 29 0,1 1 0,0 0 0,1 1 0,-1 0 0,1 1 0,0 0 0,23-1 0,97 2 0,-84 3 0,7-2 0,-35-1 0,0 2 0,0 0 0,0 1 0,0 1 0,23 6 0,-39-7 0,1 1 0,-1 0 0,0 1 0,0-1 0,0 1 0,0 0 0,0 0 0,-1 1 0,1-1 0,-1 1 0,0 0 0,0 0 0,0 1 0,-1-1 0,1 1 0,-1 0 0,0-1 0,-1 1 0,1 1 0,-1-1 0,3 10 0,0 7 0,-1 0 0,-1 0 0,-1 0 0,-1 32 0,-1-29 0,1-1 0,5 28 0,3 22 0,-8-54 0,1 0 0,8 32 0,-8-45 0,1-1 0,-1 1 0,1-1 0,0 0 0,0 0 0,1 0 0,0 0 0,0-1 0,0 0 0,1 1 0,8 7 0,166 129 0,-173-136 0,0-1 0,0 1 0,1-2 0,-1 1 0,1-1 0,1 0 0,-1 0 0,11 3 0,-12-5 0,0-1 0,-1 0 0,1-1 0,0 1 0,-1-1 0,1 0 0,0-1 0,-1 1 0,1-1 0,-1-1 0,1 1 0,-1-1 0,6-1 0,35-16 0,-1-1 0,-1-3 0,0-1 0,-2-3 0,-1-1 0,59-53 0,-92 73 0,0 0 0,0 0 0,-1-1 0,-1 0 0,0-1 0,0 1 0,0-1 0,-1-1 0,-1 1 0,0 0 0,0-1 0,2-14 0,0-8 0,-2-1 0,-1-57 0,0 9 0,9-1 0,-7 53 0,2-51 0,-7 3 0,-4-1 0,-14-81 0,9 109 0,-3 1 0,-2 0 0,-2 2 0,-27-59 0,28 76 0,2 0 0,2-1 0,1 0 0,1-1 0,1 0 0,3 0 0,0 0 0,2-1 0,2-44 0,2 65 0,1 0 0,0 0 0,1 0 0,0 1 0,1-1 0,0 1 0,1 0 0,0 0 0,1 0 0,1 1 0,14-20 0,-15 20 0,0-1 0,-2 1 0,1-1 0,-1 0 0,-1 0 0,0-1 0,-1 1 0,0 0 0,-1-1 0,-1-15 0,1 7 0,1 0 0,7-31 0,-6 43 0,1 0 0,0 0 0,0 0 0,1 0 0,0 1 0,0 0 0,1 0 0,0 0 0,10-9 0,72-62 0,-55 52 0,40-43 0,-47 43 0,49-39 0,-41 41 0,0-1 0,56-59 0,-81 76 0,0-2 0,-1 1 0,-1-1 0,0-1 0,0 1 0,-1-1 0,0 0 0,-1-1 0,-1 1 0,0-1 0,-1 0 0,0 0 0,2-20 0,-2 2 0,2-1 0,13-41 0,4-25 0,-14 49 0,-2 15 0,-1 0 0,0-43 0,-3-62 0,-6-134 0,0 250 0,-1 0 0,-1 1 0,-1 0 0,-10-23 0,1 2 0,10 28 0,-1 1 0,0 0 0,-1 1 0,0 0 0,-1 0 0,-1 1 0,0 0 0,-1 1 0,0 0 0,0 0 0,-18-11 0,-18-11 0,-87-44 0,126 72 0,-12-5 0,0 1 0,0 0 0,-1 2 0,0 0 0,-31-5 0,44 10 0,-1 1 0,0 0 0,1 0 0,-1 1 0,0 0 0,1 1 0,-1 0 0,0 0 0,1 1 0,-1 0 0,1 0 0,0 1 0,-1 0 0,1 1 0,1 0 0,-14 8 0,-190 162 0,207-168 0,0 0 0,0 0 0,0 0 0,1 1 0,0-1 0,1 1 0,-1 0 0,1 0 0,0 0 0,1 0 0,0 0 0,0 0 0,0 1 0,1 8 0,-3 20 0,1-26 0,-2 19 0,-1 0 0,-1 0 0,-14 38 0,5-23 0,3 0 0,2 0 0,-8 81 0,-10 45 0,27-166 0,-2 16 0,-2 0 0,-1-1 0,0 0 0,-1 0 0,-1 0 0,-17 26 0,19-33 0,1 1 0,0-1 0,0 1 0,1 0 0,1 0 0,0 1 0,-1 25 0,-11 40 0,12-68 0,-1 0 0,0 0 0,-1 0 0,0-1 0,-1 0 0,0 0 0,0 0 0,-1-1 0,0 0 0,-1 0 0,0-1 0,-1 0 0,1 0 0,-1-1 0,-1 0 0,1 0 0,-1-1 0,-1-1 0,1 0 0,-16 6 0,3-3 0,-1-1 0,1-1 0,-1-1 0,0-1 0,-37 1 0,-126-7 0,98-1 0,38 2 0,-96-6 0,128 5 0,0-2 0,0 0 0,1-1 0,-1-1 0,-30-15 0,-3-3 0,-1 3 0,-71-19 0,101 32 0,0 0 0,0-2 0,1-1 0,1 0 0,0-2 0,-28-21 0,-74-43 0,0 1 0,109 66 0,0 0 0,1-2 0,0 0 0,1 0 0,1-1 0,-12-16 0,19 21 0,0-1 0,1 0 0,0 0 0,1 1 0,-1-2 0,2 1 0,-1 0 0,1 0 0,1 0 0,0-1 0,1-10 0,-1 5 0,0 0 0,-2 0 0,-2-19 0,-38-154 0,40 183 0,0 0 0,0 0 0,0 1 0,-1-1 0,0 0 0,0 1 0,0 0 0,0 0 0,-1 0 0,1 0 0,-1 1 0,-5-4 0,-58-37 0,22 16 0,-72-45 0,87 57 0,1-1 0,1-1 0,1-1 0,1-2 0,0-1 0,-36-40 0,50 47 0,0 0 0,-1 2 0,-1-1 0,0 2 0,0 0 0,-1 0 0,-1 2 0,-24-14 0,34 20 0,0 1 0,0-1 0,1-1 0,0 1 0,0-1 0,0 0 0,0 0 0,1-1 0,-8-10 0,7 7 0,-1 1 0,-1 1 0,1-1 0,-10-7 0,-21-18 0,-35-40 0,-5-5 0,42 51 0,0 1 0,-2 2 0,-67-33 0,33 20 0,-75-27 0,118 54 0,0 2 0,0 1 0,-1 1 0,0 1 0,0 2 0,-36 0 0,-102-9 0,8 0 0,145 11 0,1 0 0,-1-1 0,0 0 0,0-1 0,1-1 0,-1 0 0,1-1 0,-23-12 0,-4-6 0,-50-39 0,-2 0 0,28 22 0,-140-76 0,191 110 0,-1 2 0,0-1 0,0 2 0,0 0 0,0 0 0,-26 0 0,-93 6 0,48 1 0,7-5 0,20 0 0,-81 9 0,119-6 0,1 2 0,0 0 0,0 1 0,0 1 0,1 1 0,0 0 0,0 2 0,-19 11 0,-18 15 0,7-6 0,1 2 0,2 1 0,-51 49 0,85-68 0,0 0 0,1 1 0,0 0 0,2 1 0,-13 26 0,16-28 0,-1-1 0,0 1 0,-1-1 0,0-1 0,-1 0 0,0 0 0,-1 0 0,0-1 0,-22 18 0,17-19 0,0-1 0,-1-1 0,-24 9 0,29-12 0,0-1 0,0 2 0,1-1 0,-1 1 0,1 0 0,0 1 0,0 0 0,1 1 0,0 0 0,-14 15 0,11-10 0,2 1 0,-1 0 0,1 0 0,1 1 0,0 1 0,2-1 0,-1 1 0,1 0 0,1 1 0,1-1 0,0 1 0,2 0 0,-1 0 0,1 20 0,1-24 0,0-1 0,-1 1 0,0-1 0,-1 0 0,0 0 0,-7 17 0,5-16 0,0 1 0,1-1 0,1 1 0,0 0 0,-1 16 0,4-14 0,1 1 0,0-1 0,1 1 0,0-1 0,2 0 0,-1 0 0,2 0 0,0 0 0,1-1 0,0 0 0,1 0 0,1 0 0,10 14 0,14 13 0,1-1 0,62 56 0,-7-7 0,25 24 0,-94-95 0,0 1 0,-1 0 0,-1 2 0,-1 0 0,0 1 0,19 38 0,-29-50 0,1 0 0,0 0 0,1-1 0,0 0 0,0-1 0,1 1 0,0-2 0,0 1 0,1-1 0,15 8 0,43 36 0,-66-49 0,0 1 0,0-1 0,0 1 0,0 0 0,0-1 0,-1 1 0,1 0 0,-1 0 0,1 0 0,-1 1 0,0-1 0,-1 0 0,1 0 0,0 0 0,-1 1 0,0-1 0,0 0 0,0 1 0,0-1 0,0 0 0,-1 1 0,1-1 0,-2 5 0,-3 8 0,-1-1 0,-1 1 0,-13 24 0,-4 7 0,21-40 0,1 1 0,0-1 0,-1 1 0,0-1 0,-1 0 0,1 0 0,-1 0 0,-1 0 0,1-1 0,-1 0 0,-1 0 0,1 0 0,-1 0 0,0-1 0,0 0 0,-9 6 0,-3 0 0,1 1 0,0 1 0,1 1 0,0 0 0,1 1 0,1 0 0,1 1 0,0 1 0,1 0 0,-10 19 0,15-26 0,0 0 0,-1-1 0,0 0 0,-1 0 0,-17 13 0,-23 24 0,44-40 0,-13 17 0,-1-1 0,-1-1 0,-32 26 0,44-39 0,0 1 0,0 0 0,1 0 0,1 1 0,-1 0 0,1 0 0,1 0 0,0 1 0,1 0 0,0 0 0,-5 20 0,-15 37 0,11-41 0,2 1 0,1 0 0,1 1 0,2 0 0,1 0 0,1 1 0,1 0 0,1 49 0,5 26 0,-3 144 0,-11-162 0,-1 29 0,12-59 0,4 190 0,20-120 0,-23-116-62,0-1 0,2 1 0,-1-1 0,1 1 0,1-1 0,0 1 0,0-1 0,1 0 0,0 0 0,1-1 0,0 1 0,0-1-1,1 0 1,0 0 0,1-1 0,0 0 0,0 0 0,1 0 0,0-1 0,0-1 0,12 8 0,1-1-6764</inkml:trace>
+</inkml:ink>
 </file>
 
 <file path=ppt/slideLayouts/slideLayout1.xml><?xml version="1.0" encoding="utf-8"?>
@@ -149,10 +221,9 @@
           <a:lstStyle/>
           <a:p>
             <a:r>
-              <a:rPr lang="en-US" smtClean="0"/>
+              <a:rPr lang="en-US"/>
               <a:t>Click to edit Master title style</a:t>
             </a:r>
-            <a:endParaRPr lang="en-US"/>
           </a:p>
         </p:txBody>
       </p:sp>
@@ -268,10 +339,9 @@
           </a:lstStyle>
           <a:p>
             <a:r>
-              <a:rPr lang="en-US" smtClean="0"/>
+              <a:rPr lang="en-US"/>
               <a:t>Click to edit Master subtitle style</a:t>
             </a:r>
-            <a:endParaRPr lang="en-US"/>
           </a:p>
         </p:txBody>
       </p:sp>
@@ -292,7 +362,7 @@
           <a:p>
             <a:fld id="{5BCAD085-E8A6-8845-BD4E-CB4CCA059FC4}" type="datetimeFigureOut">
               <a:rPr lang="en-US" smtClean="0"/>
-              <a:t>1/27/13</a:t>
+              <a:t>10/26/2026</a:t>
             </a:fld>
             <a:endParaRPr lang="en-US"/>
           </a:p>
@@ -386,10 +456,9 @@
           <a:lstStyle/>
           <a:p>
             <a:r>
-              <a:rPr lang="en-US" smtClean="0"/>
+              <a:rPr lang="en-US"/>
               <a:t>Click to edit Master title style</a:t>
             </a:r>
-            <a:endParaRPr lang="en-US"/>
           </a:p>
         </p:txBody>
       </p:sp>
@@ -410,38 +479,37 @@
           <a:p>
             <a:pPr lvl="0"/>
             <a:r>
-              <a:rPr lang="en-US" smtClean="0"/>
+              <a:rPr lang="en-US"/>
               <a:t>Click to edit Master text styles</a:t>
             </a:r>
           </a:p>
           <a:p>
             <a:pPr lvl="1"/>
             <a:r>
-              <a:rPr lang="en-US" smtClean="0"/>
+              <a:rPr lang="en-US"/>
               <a:t>Second level</a:t>
             </a:r>
           </a:p>
           <a:p>
             <a:pPr lvl="2"/>
             <a:r>
-              <a:rPr lang="en-US" smtClean="0"/>
+              <a:rPr lang="en-US"/>
               <a:t>Third level</a:t>
             </a:r>
           </a:p>
           <a:p>
             <a:pPr lvl="3"/>
             <a:r>
-              <a:rPr lang="en-US" smtClean="0"/>
+              <a:rPr lang="en-US"/>
               <a:t>Fourth level</a:t>
             </a:r>
           </a:p>
           <a:p>
             <a:pPr lvl="4"/>
             <a:r>
-              <a:rPr lang="en-US" smtClean="0"/>
+              <a:rPr lang="en-US"/>
               <a:t>Fifth level</a:t>
             </a:r>
-            <a:endParaRPr lang="en-US"/>
           </a:p>
         </p:txBody>
       </p:sp>
@@ -462,7 +530,7 @@
           <a:p>
             <a:fld id="{5BCAD085-E8A6-8845-BD4E-CB4CCA059FC4}" type="datetimeFigureOut">
               <a:rPr lang="en-US" smtClean="0"/>
-              <a:t>1/27/13</a:t>
+              <a:t>10/26/2026</a:t>
             </a:fld>
             <a:endParaRPr lang="en-US"/>
           </a:p>
@@ -561,10 +629,9 @@
           <a:lstStyle/>
           <a:p>
             <a:r>
-              <a:rPr lang="en-US" smtClean="0"/>
+              <a:rPr lang="en-US"/>
               <a:t>Click to edit Master title style</a:t>
             </a:r>
-            <a:endParaRPr lang="en-US"/>
           </a:p>
         </p:txBody>
       </p:sp>
@@ -590,38 +657,37 @@
           <a:p>
             <a:pPr lvl="0"/>
             <a:r>
-              <a:rPr lang="en-US" smtClean="0"/>
+              <a:rPr lang="en-US"/>
               <a:t>Click to edit Master text styles</a:t>
             </a:r>
           </a:p>
           <a:p>
             <a:pPr lvl="1"/>
             <a:r>
-              <a:rPr lang="en-US" smtClean="0"/>
+              <a:rPr lang="en-US"/>
               <a:t>Second level</a:t>
             </a:r>
           </a:p>
           <a:p>
             <a:pPr lvl="2"/>
             <a:r>
-              <a:rPr lang="en-US" smtClean="0"/>
+              <a:rPr lang="en-US"/>
               <a:t>Third level</a:t>
             </a:r>
           </a:p>
           <a:p>
             <a:pPr lvl="3"/>
             <a:r>
-              <a:rPr lang="en-US" smtClean="0"/>
+              <a:rPr lang="en-US"/>
               <a:t>Fourth level</a:t>
             </a:r>
           </a:p>
           <a:p>
             <a:pPr lvl="4"/>
             <a:r>
-              <a:rPr lang="en-US" smtClean="0"/>
+              <a:rPr lang="en-US"/>
               <a:t>Fifth level</a:t>
             </a:r>
-            <a:endParaRPr lang="en-US"/>
           </a:p>
         </p:txBody>
       </p:sp>
@@ -642,7 +708,7 @@
           <a:p>
             <a:fld id="{5BCAD085-E8A6-8845-BD4E-CB4CCA059FC4}" type="datetimeFigureOut">
               <a:rPr lang="en-US" smtClean="0"/>
-              <a:t>1/27/13</a:t>
+              <a:t>10/26/2026</a:t>
             </a:fld>
             <a:endParaRPr lang="en-US"/>
           </a:p>
@@ -736,10 +802,9 @@
           <a:lstStyle/>
           <a:p>
             <a:r>
-              <a:rPr lang="en-US" smtClean="0"/>
+              <a:rPr lang="en-US"/>
               <a:t>Click to edit Master title style</a:t>
             </a:r>
-            <a:endParaRPr lang="en-US"/>
           </a:p>
         </p:txBody>
       </p:sp>
@@ -760,38 +825,37 @@
           <a:p>
             <a:pPr lvl="0"/>
             <a:r>
-              <a:rPr lang="en-US" smtClean="0"/>
+              <a:rPr lang="en-US"/>
               <a:t>Click to edit Master text styles</a:t>
             </a:r>
           </a:p>
           <a:p>
             <a:pPr lvl="1"/>
             <a:r>
-              <a:rPr lang="en-US" smtClean="0"/>
+              <a:rPr lang="en-US"/>
               <a:t>Second level</a:t>
             </a:r>
           </a:p>
           <a:p>
             <a:pPr lvl="2"/>
             <a:r>
-              <a:rPr lang="en-US" smtClean="0"/>
+              <a:rPr lang="en-US"/>
               <a:t>Third level</a:t>
             </a:r>
           </a:p>
           <a:p>
             <a:pPr lvl="3"/>
             <a:r>
-              <a:rPr lang="en-US" smtClean="0"/>
+              <a:rPr lang="en-US"/>
               <a:t>Fourth level</a:t>
             </a:r>
           </a:p>
           <a:p>
             <a:pPr lvl="4"/>
             <a:r>
-              <a:rPr lang="en-US" smtClean="0"/>
+              <a:rPr lang="en-US"/>
               <a:t>Fifth level</a:t>
             </a:r>
-            <a:endParaRPr lang="en-US"/>
           </a:p>
         </p:txBody>
       </p:sp>
@@ -812,7 +876,7 @@
           <a:p>
             <a:fld id="{5BCAD085-E8A6-8845-BD4E-CB4CCA059FC4}" type="datetimeFigureOut">
               <a:rPr lang="en-US" smtClean="0"/>
-              <a:t>1/27/13</a:t>
+              <a:t>10/26/2026</a:t>
             </a:fld>
             <a:endParaRPr lang="en-US"/>
           </a:p>
@@ -915,10 +979,9 @@
           </a:lstStyle>
           <a:p>
             <a:r>
-              <a:rPr lang="en-US" smtClean="0"/>
+              <a:rPr lang="en-US"/>
               <a:t>Click to edit Master title style</a:t>
             </a:r>
-            <a:endParaRPr lang="en-US"/>
           </a:p>
         </p:txBody>
       </p:sp>
@@ -1035,7 +1098,7 @@
           <a:p>
             <a:pPr lvl="0"/>
             <a:r>
-              <a:rPr lang="en-US" smtClean="0"/>
+              <a:rPr lang="en-US"/>
               <a:t>Click to edit Master text styles</a:t>
             </a:r>
           </a:p>
@@ -1058,7 +1121,7 @@
           <a:p>
             <a:fld id="{5BCAD085-E8A6-8845-BD4E-CB4CCA059FC4}" type="datetimeFigureOut">
               <a:rPr lang="en-US" smtClean="0"/>
-              <a:t>1/27/13</a:t>
+              <a:t>10/26/2026</a:t>
             </a:fld>
             <a:endParaRPr lang="en-US"/>
           </a:p>
@@ -1152,10 +1215,9 @@
           <a:lstStyle/>
           <a:p>
             <a:r>
-              <a:rPr lang="en-US" smtClean="0"/>
+              <a:rPr lang="en-US"/>
               <a:t>Click to edit Master title style</a:t>
             </a:r>
-            <a:endParaRPr lang="en-US"/>
           </a:p>
         </p:txBody>
       </p:sp>
@@ -1209,38 +1271,37 @@
           <a:p>
             <a:pPr lvl="0"/>
             <a:r>
-              <a:rPr lang="en-US" smtClean="0"/>
+              <a:rPr lang="en-US"/>
               <a:t>Click to edit Master text styles</a:t>
             </a:r>
           </a:p>
           <a:p>
             <a:pPr lvl="1"/>
             <a:r>
-              <a:rPr lang="en-US" smtClean="0"/>
+              <a:rPr lang="en-US"/>
               <a:t>Second level</a:t>
             </a:r>
           </a:p>
           <a:p>
             <a:pPr lvl="2"/>
             <a:r>
-              <a:rPr lang="en-US" smtClean="0"/>
+              <a:rPr lang="en-US"/>
               <a:t>Third level</a:t>
             </a:r>
           </a:p>
           <a:p>
             <a:pPr lvl="3"/>
             <a:r>
-              <a:rPr lang="en-US" smtClean="0"/>
+              <a:rPr lang="en-US"/>
               <a:t>Fourth level</a:t>
             </a:r>
           </a:p>
           <a:p>
             <a:pPr lvl="4"/>
             <a:r>
-              <a:rPr lang="en-US" smtClean="0"/>
+              <a:rPr lang="en-US"/>
               <a:t>Fifth level</a:t>
             </a:r>
-            <a:endParaRPr lang="en-US"/>
           </a:p>
         </p:txBody>
       </p:sp>
@@ -1294,38 +1355,37 @@
           <a:p>
             <a:pPr lvl="0"/>
             <a:r>
-              <a:rPr lang="en-US" smtClean="0"/>
+              <a:rPr lang="en-US"/>
               <a:t>Click to edit Master text styles</a:t>
             </a:r>
           </a:p>
           <a:p>
             <a:pPr lvl="1"/>
             <a:r>
-              <a:rPr lang="en-US" smtClean="0"/>
+              <a:rPr lang="en-US"/>
               <a:t>Second level</a:t>
             </a:r>
           </a:p>
           <a:p>
             <a:pPr lvl="2"/>
             <a:r>
-              <a:rPr lang="en-US" smtClean="0"/>
+              <a:rPr lang="en-US"/>
               <a:t>Third level</a:t>
             </a:r>
           </a:p>
           <a:p>
             <a:pPr lvl="3"/>
             <a:r>
-              <a:rPr lang="en-US" smtClean="0"/>
+              <a:rPr lang="en-US"/>
               <a:t>Fourth level</a:t>
             </a:r>
           </a:p>
           <a:p>
             <a:pPr lvl="4"/>
             <a:r>
-              <a:rPr lang="en-US" smtClean="0"/>
+              <a:rPr lang="en-US"/>
               <a:t>Fifth level</a:t>
             </a:r>
-            <a:endParaRPr lang="en-US"/>
           </a:p>
         </p:txBody>
       </p:sp>
@@ -1346,7 +1406,7 @@
           <a:p>
             <a:fld id="{5BCAD085-E8A6-8845-BD4E-CB4CCA059FC4}" type="datetimeFigureOut">
               <a:rPr lang="en-US" smtClean="0"/>
-              <a:t>1/27/13</a:t>
+              <a:t>10/26/2026</a:t>
             </a:fld>
             <a:endParaRPr lang="en-US"/>
           </a:p>
@@ -1444,10 +1504,9 @@
           </a:lstStyle>
           <a:p>
             <a:r>
-              <a:rPr lang="en-US" smtClean="0"/>
+              <a:rPr lang="en-US"/>
               <a:t>Click to edit Master title style</a:t>
             </a:r>
-            <a:endParaRPr lang="en-US"/>
           </a:p>
         </p:txBody>
       </p:sp>
@@ -1510,7 +1569,7 @@
           <a:p>
             <a:pPr lvl="0"/>
             <a:r>
-              <a:rPr lang="en-US" smtClean="0"/>
+              <a:rPr lang="en-US"/>
               <a:t>Click to edit Master text styles</a:t>
             </a:r>
           </a:p>
@@ -1566,38 +1625,37 @@
           <a:p>
             <a:pPr lvl="0"/>
             <a:r>
-              <a:rPr lang="en-US" smtClean="0"/>
+              <a:rPr lang="en-US"/>
               <a:t>Click to edit Master text styles</a:t>
             </a:r>
           </a:p>
           <a:p>
             <a:pPr lvl="1"/>
             <a:r>
-              <a:rPr lang="en-US" smtClean="0"/>
+              <a:rPr lang="en-US"/>
               <a:t>Second level</a:t>
             </a:r>
           </a:p>
           <a:p>
             <a:pPr lvl="2"/>
             <a:r>
-              <a:rPr lang="en-US" smtClean="0"/>
+              <a:rPr lang="en-US"/>
               <a:t>Third level</a:t>
             </a:r>
           </a:p>
           <a:p>
             <a:pPr lvl="3"/>
             <a:r>
-              <a:rPr lang="en-US" smtClean="0"/>
+              <a:rPr lang="en-US"/>
               <a:t>Fourth level</a:t>
             </a:r>
           </a:p>
           <a:p>
             <a:pPr lvl="4"/>
             <a:r>
-              <a:rPr lang="en-US" smtClean="0"/>
+              <a:rPr lang="en-US"/>
               <a:t>Fifth level</a:t>
             </a:r>
-            <a:endParaRPr lang="en-US"/>
           </a:p>
         </p:txBody>
       </p:sp>
@@ -1660,7 +1718,7 @@
           <a:p>
             <a:pPr lvl="0"/>
             <a:r>
-              <a:rPr lang="en-US" smtClean="0"/>
+              <a:rPr lang="en-US"/>
               <a:t>Click to edit Master text styles</a:t>
             </a:r>
           </a:p>
@@ -1716,38 +1774,37 @@
           <a:p>
             <a:pPr lvl="0"/>
             <a:r>
-              <a:rPr lang="en-US" smtClean="0"/>
+              <a:rPr lang="en-US"/>
               <a:t>Click to edit Master text styles</a:t>
             </a:r>
           </a:p>
           <a:p>
             <a:pPr lvl="1"/>
             <a:r>
-              <a:rPr lang="en-US" smtClean="0"/>
+              <a:rPr lang="en-US"/>
               <a:t>Second level</a:t>
             </a:r>
           </a:p>
           <a:p>
             <a:pPr lvl="2"/>
             <a:r>
-              <a:rPr lang="en-US" smtClean="0"/>
+              <a:rPr lang="en-US"/>
               <a:t>Third level</a:t>
             </a:r>
           </a:p>
           <a:p>
             <a:pPr lvl="3"/>
             <a:r>
-              <a:rPr lang="en-US" smtClean="0"/>
+              <a:rPr lang="en-US"/>
               <a:t>Fourth level</a:t>
             </a:r>
           </a:p>
           <a:p>
             <a:pPr lvl="4"/>
             <a:r>
-              <a:rPr lang="en-US" smtClean="0"/>
+              <a:rPr lang="en-US"/>
               <a:t>Fifth level</a:t>
             </a:r>
-            <a:endParaRPr lang="en-US"/>
           </a:p>
         </p:txBody>
       </p:sp>
@@ -1768,7 +1825,7 @@
           <a:p>
             <a:fld id="{5BCAD085-E8A6-8845-BD4E-CB4CCA059FC4}" type="datetimeFigureOut">
               <a:rPr lang="en-US" smtClean="0"/>
-              <a:t>1/27/13</a:t>
+              <a:t>10/26/2026</a:t>
             </a:fld>
             <a:endParaRPr lang="en-US"/>
           </a:p>
@@ -1862,10 +1919,9 @@
           <a:lstStyle/>
           <a:p>
             <a:r>
-              <a:rPr lang="en-US" smtClean="0"/>
+              <a:rPr lang="en-US"/>
               <a:t>Click to edit Master title style</a:t>
             </a:r>
-            <a:endParaRPr lang="en-US"/>
           </a:p>
         </p:txBody>
       </p:sp>
@@ -1886,7 +1942,7 @@
           <a:p>
             <a:fld id="{5BCAD085-E8A6-8845-BD4E-CB4CCA059FC4}" type="datetimeFigureOut">
               <a:rPr lang="en-US" smtClean="0"/>
-              <a:t>1/27/13</a:t>
+              <a:t>10/26/2026</a:t>
             </a:fld>
             <a:endParaRPr lang="en-US"/>
           </a:p>
@@ -1981,7 +2037,7 @@
           <a:p>
             <a:fld id="{5BCAD085-E8A6-8845-BD4E-CB4CCA059FC4}" type="datetimeFigureOut">
               <a:rPr lang="en-US" smtClean="0"/>
-              <a:t>1/27/13</a:t>
+              <a:t>10/26/2026</a:t>
             </a:fld>
             <a:endParaRPr lang="en-US"/>
           </a:p>
@@ -2084,10 +2140,9 @@
           </a:lstStyle>
           <a:p>
             <a:r>
-              <a:rPr lang="en-US" smtClean="0"/>
+              <a:rPr lang="en-US"/>
               <a:t>Click to edit Master title style</a:t>
             </a:r>
-            <a:endParaRPr lang="en-US"/>
           </a:p>
         </p:txBody>
       </p:sp>
@@ -2141,38 +2196,37 @@
           <a:p>
             <a:pPr lvl="0"/>
             <a:r>
-              <a:rPr lang="en-US" smtClean="0"/>
+              <a:rPr lang="en-US"/>
               <a:t>Click to edit Master text styles</a:t>
             </a:r>
           </a:p>
           <a:p>
             <a:pPr lvl="1"/>
             <a:r>
-              <a:rPr lang="en-US" smtClean="0"/>
+              <a:rPr lang="en-US"/>
               <a:t>Second level</a:t>
             </a:r>
           </a:p>
           <a:p>
             <a:pPr lvl="2"/>
             <a:r>
-              <a:rPr lang="en-US" smtClean="0"/>
+              <a:rPr lang="en-US"/>
               <a:t>Third level</a:t>
             </a:r>
           </a:p>
           <a:p>
             <a:pPr lvl="3"/>
             <a:r>
-              <a:rPr lang="en-US" smtClean="0"/>
+              <a:rPr lang="en-US"/>
               <a:t>Fourth level</a:t>
             </a:r>
           </a:p>
           <a:p>
             <a:pPr lvl="4"/>
             <a:r>
-              <a:rPr lang="en-US" smtClean="0"/>
+              <a:rPr lang="en-US"/>
               <a:t>Fifth level</a:t>
             </a:r>
-            <a:endParaRPr lang="en-US"/>
           </a:p>
         </p:txBody>
       </p:sp>
@@ -2235,7 +2289,7 @@
           <a:p>
             <a:pPr lvl="0"/>
             <a:r>
-              <a:rPr lang="en-US" smtClean="0"/>
+              <a:rPr lang="en-US"/>
               <a:t>Click to edit Master text styles</a:t>
             </a:r>
           </a:p>
@@ -2258,7 +2312,7 @@
           <a:p>
             <a:fld id="{5BCAD085-E8A6-8845-BD4E-CB4CCA059FC4}" type="datetimeFigureOut">
               <a:rPr lang="en-US" smtClean="0"/>
-              <a:t>1/27/13</a:t>
+              <a:t>10/26/2026</a:t>
             </a:fld>
             <a:endParaRPr lang="en-US"/>
           </a:p>
@@ -2361,10 +2415,9 @@
           </a:lstStyle>
           <a:p>
             <a:r>
-              <a:rPr lang="en-US" smtClean="0"/>
+              <a:rPr lang="en-US"/>
               <a:t>Click to edit Master title style</a:t>
             </a:r>
-            <a:endParaRPr lang="en-US"/>
           </a:p>
         </p:txBody>
       </p:sp>
@@ -2488,7 +2541,7 @@
           <a:p>
             <a:pPr lvl="0"/>
             <a:r>
-              <a:rPr lang="en-US" smtClean="0"/>
+              <a:rPr lang="en-US"/>
               <a:t>Click to edit Master text styles</a:t>
             </a:r>
           </a:p>
@@ -2511,7 +2564,7 @@
           <a:p>
             <a:fld id="{5BCAD085-E8A6-8845-BD4E-CB4CCA059FC4}" type="datetimeFigureOut">
               <a:rPr lang="en-US" smtClean="0"/>
-              <a:t>1/27/13</a:t>
+              <a:t>10/26/2026</a:t>
             </a:fld>
             <a:endParaRPr lang="en-US"/>
           </a:p>
@@ -2620,10 +2673,9 @@
           <a:lstStyle/>
           <a:p>
             <a:r>
-              <a:rPr lang="en-US" smtClean="0"/>
+              <a:rPr lang="en-US"/>
               <a:t>Click to edit Master title style</a:t>
             </a:r>
-            <a:endParaRPr lang="en-US"/>
           </a:p>
         </p:txBody>
       </p:sp>
@@ -2654,38 +2706,37 @@
           <a:p>
             <a:pPr lvl="0"/>
             <a:r>
-              <a:rPr lang="en-US" smtClean="0"/>
+              <a:rPr lang="en-US"/>
               <a:t>Click to edit Master text styles</a:t>
             </a:r>
           </a:p>
           <a:p>
             <a:pPr lvl="1"/>
             <a:r>
-              <a:rPr lang="en-US" smtClean="0"/>
+              <a:rPr lang="en-US"/>
               <a:t>Second level</a:t>
             </a:r>
           </a:p>
           <a:p>
             <a:pPr lvl="2"/>
             <a:r>
-              <a:rPr lang="en-US" smtClean="0"/>
+              <a:rPr lang="en-US"/>
               <a:t>Third level</a:t>
             </a:r>
           </a:p>
           <a:p>
             <a:pPr lvl="3"/>
             <a:r>
-              <a:rPr lang="en-US" smtClean="0"/>
+              <a:rPr lang="en-US"/>
               <a:t>Fourth level</a:t>
             </a:r>
           </a:p>
           <a:p>
             <a:pPr lvl="4"/>
             <a:r>
-              <a:rPr lang="en-US" smtClean="0"/>
+              <a:rPr lang="en-US"/>
               <a:t>Fifth level</a:t>
             </a:r>
-            <a:endParaRPr lang="en-US"/>
           </a:p>
         </p:txBody>
       </p:sp>
@@ -2724,7 +2775,7 @@
           <a:p>
             <a:fld id="{5BCAD085-E8A6-8845-BD4E-CB4CCA059FC4}" type="datetimeFigureOut">
               <a:rPr lang="en-US" smtClean="0"/>
-              <a:t>1/27/13</a:t>
+              <a:t>10/26/2026</a:t>
             </a:fld>
             <a:endParaRPr lang="en-US"/>
           </a:p>
@@ -3083,7 +3134,7 @@
 </file>
 
 <file path=ppt/slides/slide1.xml><?xml version="1.0" encoding="utf-8"?>
-<p:sld xmlns:a="http://schemas.openxmlformats.org/drawingml/2006/main" xmlns:p="http://schemas.openxmlformats.org/presentationml/2006/main" xmlns:r="http://schemas.openxmlformats.org/officeDocument/2006/relationships">
+<p:sld xmlns:a="http://schemas.openxmlformats.org/drawingml/2006/main" xmlns:r="http://schemas.openxmlformats.org/officeDocument/2006/relationships" xmlns:p="http://schemas.openxmlformats.org/presentationml/2006/main">
   <p:cSld>
     <p:spTree>
       <p:nvGrpSpPr>
@@ -3091,7 +3142,14 @@
         <p:cNvGrpSpPr/>
         <p:nvPr/>
       </p:nvGrpSpPr>
-      <p:grpSpPr/>
+      <p:grpSpPr>
+        <a:xfrm>
+          <a:off x="0" y="0"/>
+          <a:ext cx="0" cy="0"/>
+          <a:chOff x="0" y="0"/>
+          <a:chExt cx="0" cy="0"/>
+        </a:xfrm>
+      </p:grpSpPr>
       <p:pic>
         <p:nvPicPr>
           <p:cNvPr id="2" name="Picture 1" descr="visual_WCA_1.png"/>
@@ -3181,6 +3239,7 @@
             <a:pPr>
               <a:defRPr sz="800" b="0"/>
             </a:pPr>
+            <a:endParaRPr/>
           </a:p>
           <a:p>
             <a:pPr>
@@ -3225,7 +3284,7 @@
 </file>
 
 <file path=ppt/slides/slide2.xml><?xml version="1.0" encoding="utf-8"?>
-<p:sld xmlns:a="http://schemas.openxmlformats.org/drawingml/2006/main" xmlns:p="http://schemas.openxmlformats.org/presentationml/2006/main" xmlns:r="http://schemas.openxmlformats.org/officeDocument/2006/relationships">
+<p:sld xmlns:a="http://schemas.openxmlformats.org/drawingml/2006/main" xmlns:r="http://schemas.openxmlformats.org/officeDocument/2006/relationships" xmlns:p="http://schemas.openxmlformats.org/presentationml/2006/main">
   <p:cSld>
     <p:spTree>
       <p:nvGrpSpPr>
@@ -3233,7 +3292,14 @@
         <p:cNvGrpSpPr/>
         <p:nvPr/>
       </p:nvGrpSpPr>
-      <p:grpSpPr/>
+      <p:grpSpPr>
+        <a:xfrm>
+          <a:off x="0" y="0"/>
+          <a:ext cx="0" cy="0"/>
+          <a:chOff x="0" y="0"/>
+          <a:chExt cx="0" cy="0"/>
+        </a:xfrm>
+      </p:grpSpPr>
       <p:pic>
         <p:nvPicPr>
           <p:cNvPr id="2" name="Picture 1" descr="visual_WCB_1.png"/>
@@ -3323,6 +3389,7 @@
             <a:pPr>
               <a:defRPr sz="800" b="0"/>
             </a:pPr>
+            <a:endParaRPr/>
           </a:p>
           <a:p>
             <a:pPr>
@@ -3367,7 +3434,7 @@
 </file>
 
 <file path=ppt/slides/slide3.xml><?xml version="1.0" encoding="utf-8"?>
-<p:sld xmlns:a="http://schemas.openxmlformats.org/drawingml/2006/main" xmlns:p="http://schemas.openxmlformats.org/presentationml/2006/main" xmlns:r="http://schemas.openxmlformats.org/officeDocument/2006/relationships">
+<p:sld xmlns:a="http://schemas.openxmlformats.org/drawingml/2006/main" xmlns:r="http://schemas.openxmlformats.org/officeDocument/2006/relationships" xmlns:p="http://schemas.openxmlformats.org/presentationml/2006/main">
   <p:cSld>
     <p:spTree>
       <p:nvGrpSpPr>
@@ -3375,7 +3442,14 @@
         <p:cNvGrpSpPr/>
         <p:nvPr/>
       </p:nvGrpSpPr>
-      <p:grpSpPr/>
+      <p:grpSpPr>
+        <a:xfrm>
+          <a:off x="0" y="0"/>
+          <a:ext cx="0" cy="0"/>
+          <a:chOff x="0" y="0"/>
+          <a:chExt cx="0" cy="0"/>
+        </a:xfrm>
+      </p:grpSpPr>
       <p:pic>
         <p:nvPicPr>
           <p:cNvPr id="2" name="Picture 1" descr="visual_WCB_2_clipped.png"/>
@@ -3465,6 +3539,7 @@
             <a:pPr>
               <a:defRPr sz="800" b="0"/>
             </a:pPr>
+            <a:endParaRPr/>
           </a:p>
           <a:p>
             <a:pPr>
@@ -3509,7 +3584,7 @@
 </file>
 
 <file path=ppt/slides/slide4.xml><?xml version="1.0" encoding="utf-8"?>
-<p:sld xmlns:a="http://schemas.openxmlformats.org/drawingml/2006/main" xmlns:p="http://schemas.openxmlformats.org/presentationml/2006/main" xmlns:r="http://schemas.openxmlformats.org/officeDocument/2006/relationships">
+<p:sld xmlns:a="http://schemas.openxmlformats.org/drawingml/2006/main" xmlns:r="http://schemas.openxmlformats.org/officeDocument/2006/relationships" xmlns:p="http://schemas.openxmlformats.org/presentationml/2006/main">
   <p:cSld>
     <p:spTree>
       <p:nvGrpSpPr>
@@ -3517,7 +3592,14 @@
         <p:cNvGrpSpPr/>
         <p:nvPr/>
       </p:nvGrpSpPr>
-      <p:grpSpPr/>
+      <p:grpSpPr>
+        <a:xfrm>
+          <a:off x="0" y="0"/>
+          <a:ext cx="0" cy="0"/>
+          <a:chOff x="0" y="0"/>
+          <a:chExt cx="0" cy="0"/>
+        </a:xfrm>
+      </p:grpSpPr>
       <p:pic>
         <p:nvPicPr>
           <p:cNvPr id="2" name="Picture 1" descr="visual_WCC.png"/>
@@ -3607,6 +3689,7 @@
             <a:pPr>
               <a:defRPr sz="800" b="0"/>
             </a:pPr>
+            <a:endParaRPr/>
           </a:p>
           <a:p>
             <a:pPr>
@@ -3642,6 +3725,57 @@
           </a:p>
         </p:txBody>
       </p:sp>
+      <mc:AlternateContent xmlns:mc="http://schemas.openxmlformats.org/markup-compatibility/2006">
+        <mc:Choice xmlns:p14="http://schemas.microsoft.com/office/powerpoint/2010/main" Requires="p14">
+          <p:contentPart p14:bwMode="auto" r:id="rId3">
+            <p14:nvContentPartPr>
+              <p14:cNvPr id="8" name="Ink 7">
+                <a:extLst>
+                  <a:ext uri="{FF2B5EF4-FFF2-40B4-BE49-F238E27FC236}">
+                    <a16:creationId xmlns:a16="http://schemas.microsoft.com/office/drawing/2014/main" id="{4DDFF287-9472-81AA-7782-D707DE9F6FD3}"/>
+                  </a:ext>
+                </a:extLst>
+              </p14:cNvPr>
+              <p14:cNvContentPartPr/>
+              <p14:nvPr/>
+            </p14:nvContentPartPr>
+            <p14:xfrm>
+              <a:off x="4292691" y="2323286"/>
+              <a:ext cx="2970720" cy="3704040"/>
+            </p14:xfrm>
+          </p:contentPart>
+        </mc:Choice>
+        <mc:Fallback>
+          <p:pic>
+            <p:nvPicPr>
+              <p:cNvPr id="8" name="Ink 7">
+                <a:extLst>
+                  <a:ext uri="{FF2B5EF4-FFF2-40B4-BE49-F238E27FC236}">
+                    <a16:creationId xmlns:a16="http://schemas.microsoft.com/office/drawing/2014/main" id="{4DDFF287-9472-81AA-7782-D707DE9F6FD3}"/>
+                  </a:ext>
+                </a:extLst>
+              </p:cNvPr>
+              <p:cNvPicPr/>
+              <p:nvPr/>
+            </p:nvPicPr>
+            <p:blipFill>
+              <a:blip r:embed="rId4"/>
+              <a:stretch>
+                <a:fillRect/>
+              </a:stretch>
+            </p:blipFill>
+            <p:spPr>
+              <a:xfrm>
+                <a:off x="4286571" y="2317166"/>
+                <a:ext cx="2982960" cy="3716280"/>
+              </a:xfrm>
+              <a:prstGeom prst="rect">
+                <a:avLst/>
+              </a:prstGeom>
+            </p:spPr>
+          </p:pic>
+        </mc:Fallback>
+      </mc:AlternateContent>
     </p:spTree>
   </p:cSld>
   <p:clrMapOvr>
@@ -3651,7 +3785,7 @@
 </file>
 
 <file path=ppt/slides/slide5.xml><?xml version="1.0" encoding="utf-8"?>
-<p:sld xmlns:a="http://schemas.openxmlformats.org/drawingml/2006/main" xmlns:p="http://schemas.openxmlformats.org/presentationml/2006/main" xmlns:r="http://schemas.openxmlformats.org/officeDocument/2006/relationships">
+<p:sld xmlns:a="http://schemas.openxmlformats.org/drawingml/2006/main" xmlns:r="http://schemas.openxmlformats.org/officeDocument/2006/relationships" xmlns:p="http://schemas.openxmlformats.org/presentationml/2006/main">
   <p:cSld>
     <p:spTree>
       <p:nvGrpSpPr>
@@ -3659,7 +3793,14 @@
         <p:cNvGrpSpPr/>
         <p:nvPr/>
       </p:nvGrpSpPr>
-      <p:grpSpPr/>
+      <p:grpSpPr>
+        <a:xfrm>
+          <a:off x="0" y="0"/>
+          <a:ext cx="0" cy="0"/>
+          <a:chOff x="0" y="0"/>
+          <a:chExt cx="0" cy="0"/>
+        </a:xfrm>
+      </p:grpSpPr>
       <p:pic>
         <p:nvPicPr>
           <p:cNvPr id="2" name="Picture 1" descr="visual_WCD.png"/>
@@ -3749,6 +3890,7 @@
             <a:pPr>
               <a:defRPr sz="800" b="0"/>
             </a:pPr>
+            <a:endParaRPr/>
           </a:p>
           <a:p>
             <a:pPr>
@@ -3784,6 +3926,57 @@
           </a:p>
         </p:txBody>
       </p:sp>
+      <mc:AlternateContent xmlns:mc="http://schemas.openxmlformats.org/markup-compatibility/2006">
+        <mc:Choice xmlns:p14="http://schemas.microsoft.com/office/powerpoint/2010/main" Requires="p14">
+          <p:contentPart p14:bwMode="auto" r:id="rId3">
+            <p14:nvContentPartPr>
+              <p14:cNvPr id="4" name="Ink 3">
+                <a:extLst>
+                  <a:ext uri="{FF2B5EF4-FFF2-40B4-BE49-F238E27FC236}">
+                    <a16:creationId xmlns:a16="http://schemas.microsoft.com/office/drawing/2014/main" id="{93A10BB5-FDCF-2A65-9207-22174002C48B}"/>
+                  </a:ext>
+                </a:extLst>
+              </p14:cNvPr>
+              <p14:cNvContentPartPr/>
+              <p14:nvPr/>
+            </p14:nvContentPartPr>
+            <p14:xfrm>
+              <a:off x="4798131" y="2000366"/>
+              <a:ext cx="2561760" cy="3522600"/>
+            </p14:xfrm>
+          </p:contentPart>
+        </mc:Choice>
+        <mc:Fallback>
+          <p:pic>
+            <p:nvPicPr>
+              <p:cNvPr id="4" name="Ink 3">
+                <a:extLst>
+                  <a:ext uri="{FF2B5EF4-FFF2-40B4-BE49-F238E27FC236}">
+                    <a16:creationId xmlns:a16="http://schemas.microsoft.com/office/drawing/2014/main" id="{93A10BB5-FDCF-2A65-9207-22174002C48B}"/>
+                  </a:ext>
+                </a:extLst>
+              </p:cNvPr>
+              <p:cNvPicPr/>
+              <p:nvPr/>
+            </p:nvPicPr>
+            <p:blipFill>
+              <a:blip r:embed="rId4"/>
+              <a:stretch>
+                <a:fillRect/>
+              </a:stretch>
+            </p:blipFill>
+            <p:spPr>
+              <a:xfrm>
+                <a:off x="4792011" y="1994246"/>
+                <a:ext cx="2574000" cy="3534840"/>
+              </a:xfrm>
+              <a:prstGeom prst="rect">
+                <a:avLst/>
+              </a:prstGeom>
+            </p:spPr>
+          </p:pic>
+        </mc:Fallback>
+      </mc:AlternateContent>
     </p:spTree>
   </p:cSld>
   <p:clrMapOvr>

</xml_diff>

<commit_message>
docs(box): 20a WCC back to the generated extent (loop withdrawn)
Michael re-saved the extents deck without the slide-4 WCC loop. WCC is
now the r2 generated extent (652 sq mi, 699 undrilled); the WCD loop
re-reads byte-identical. FINDINGS §7 and the plan status updated.

Co-Authored-By: Claude Opus 5.5 <noreply@anthropic.com>
</commit_message>
<xml_diff>
--- a/docs/box/step20a-2026-10-26/extents/midland_wolfcamp_extents_2026-10-26.pptx
+++ b/docs/box/step20a-2026-10-26/extents/midland_wolfcamp_extents_2026-10-26.pptx
@@ -128,34 +128,6 @@
 </file>
 
 <file path=ppt/ink/ink1.xml><?xml version="1.0" encoding="utf-8"?>
-<inkml:ink xmlns:inkml="http://www.w3.org/2003/InkML">
-  <inkml:definitions>
-    <inkml:context xml:id="ctx0">
-      <inkml:inkSource xml:id="inkSrc0">
-        <inkml:traceFormat>
-          <inkml:channel name="X" type="integer" min="-2.14748E9" max="2.14748E9" units="cm"/>
-          <inkml:channel name="Y" type="integer" min="-2.14748E9" max="2.14748E9" units="cm"/>
-          <inkml:channel name="F" type="integer" max="32767" units="dev"/>
-        </inkml:traceFormat>
-        <inkml:channelProperties>
-          <inkml:channelProperty channel="X" name="resolution" value="1000" units="1/cm"/>
-          <inkml:channelProperty channel="Y" name="resolution" value="1000" units="1/cm"/>
-          <inkml:channelProperty channel="F" name="resolution" value="0" units="1/dev"/>
-        </inkml:channelProperties>
-      </inkml:inkSource>
-      <inkml:timestamp xml:id="ts0" timeString="2026-10-26T23:40:24.911"/>
-    </inkml:context>
-    <inkml:brush xml:id="br0">
-      <inkml:brushProperty name="width" value="0.035" units="cm"/>
-      <inkml:brushProperty name="height" value="0.035" units="cm"/>
-      <inkml:brushProperty name="color" value="#E71224"/>
-    </inkml:brush>
-  </inkml:definitions>
-  <inkml:trace contextRef="#ctx0" brushRef="#br0">50 683 24575,'2'94'0,"-5"104"0,-8-124 0,-2 21 0,1-5 0,0 3 0,12-84 0,0 1 0,0-1 0,1 0 0,0 1 0,1-1 0,0 0 0,0 0 0,1 0 0,0-1 0,1 1 0,0-1 0,0 1 0,1-1 0,0 0 0,0-1 0,1 1 0,0-1 0,14 12 0,-14-12 0,9 7 0,-1 2 0,-1-1 0,15 23 0,-24-31 0,0 1 0,-1-1 0,0 1 0,0 1 0,0-1 0,-1 0 0,0 0 0,-1 1 0,0-1 0,0 17 0,-1-11 0,0 0 0,2 0 0,-1 0 0,2 0 0,-1 0 0,2-1 0,0 1 0,1-1 0,0 0 0,14 24 0,58 103 0,-72-129 0,-1 0 0,0-1 0,-1 2 0,0-1 0,-1 0 0,0 0 0,1 18 0,4 23 0,1 1 0,-6-39 0,0 0 0,0 0 0,2 0 0,7 22 0,-1-14 0,-1-1 0,-1 1 0,-1 1 0,-1 0 0,-1-1 0,-1 2 0,-1-1 0,0 29 0,-3 58 0,-4 121 0,1-208 0,-1-1 0,-13 40 0,-1 4 0,-51 165 0,17-66 0,35-98 0,4 1 0,2 0 0,4 0 0,1 108 0,-6 30 0,-1 2 0,12 6 0,4 167 0,0-354 0,2-1 0,1 0 0,1 0 0,16 39 0,-4-12 0,-12-33 0,1-1 0,1 0 0,1-1 0,1 0 0,0-1 0,1 0 0,17 18 0,7 3 0,67 55 0,-91-81 0,-1 0 0,-1 0 0,0 1 0,0 0 0,-2 1 0,0 0 0,0 1 0,-1-1 0,-1 1 0,0 1 0,-2-1 0,1 1 0,-2 0 0,3 25 0,-2-20 0,1-2 0,0 1 0,15 33 0,-12-35 0,-2 0 0,0 0 0,-1 1 0,5 32 0,-7-16 0,-4-25 0,1 0 0,1-1 0,0 1 0,0-1 0,1 1 0,0-1 0,0 1 0,1-1 0,0 0 0,1 0 0,0 0 0,1-1 0,-1 1 0,2-1 0,7 10 0,-5-9 0,-1 0 0,0 0 0,-1 1 0,0 0 0,0 0 0,-1 1 0,5 14 0,19 82 0,-11-31 0,-1-7 0,-12-45 0,1-1 0,1 0 0,1 0 0,13 26 0,-9-25 0,-2 1 0,-1 0 0,7 33 0,-12-39 0,1 1 0,1-1 0,1 0 0,1 0 0,1-1 0,21 34 0,79 76 0,-96-114 0,26 24 0,-26-26 0,0 1 0,18 23 0,34 38 0,-49-57 0,0 1 0,0 0 0,17 29 0,-12-15 0,42 49 0,12 18 0,-68-85 0,0 0 0,-1 1 0,-1-1 0,-1 1 0,0 0 0,0 1 0,-2-1 0,2 27 0,-3-26 0,1 0 0,0-1 0,1 1 0,0-1 0,1 0 0,1 0 0,1 0 0,14 27 0,-1-16 0,1-1 0,47 44 0,-45-47 0,0 0 0,-1 2 0,21 31 0,-27-33 0,2 0 0,0-1 0,1 0 0,39 33 0,-50-47 0,1 1 0,-2 0 0,1 0 0,-1 1 0,0 0 0,-1 0 0,0 0 0,-1 0 0,1 1 0,-2 0 0,0 0 0,3 13 0,9 24 0,-3-23 0,0 0 0,2 0 0,0-2 0,2 0 0,0-1 0,37 37 0,22 29 0,-11-8 0,4-2 0,92 80 0,-9-32 0,-113-93 0,-29-26 0,-1 1 0,0 0 0,-1 0 0,0 0 0,0 1 0,0 0 0,-1 0 0,7 12 0,-4-6 0,0 0 0,2-1 0,0 0 0,0-1 0,1 0 0,0-1 0,17 12 0,43 42 0,-55-46 0,0-2 0,1 0 0,35 26 0,-44-37 0,0-1 0,0 0 0,1 0 0,0-1 0,0 0 0,0-1 0,0 0 0,0 0 0,0-1 0,1-1 0,18 2 0,274-32 0,-191 15 0,-67 8 0,-1-2 0,0-1 0,-1-3 0,0-1 0,-1-2 0,0-2 0,52-30 0,-76 38 0,-1 2 0,1 0 0,0 1 0,32-6 0,32-11 0,-28 4 0,0 2 0,1 3 0,1 2 0,0 3 0,1 2 0,-1 2 0,1 3 0,70 6 0,-111 0 0,0-1 0,0 2 0,0 0 0,0 1 0,-1 1 0,0 0 0,0 1 0,0 1 0,13 10 0,-5-4 0,0-1 0,33 14 0,-29-18 0,17 9 0,1-2 0,1-3 0,76 15 0,-103-24 0,0 1 0,0 1 0,-1 1 0,0 0 0,0 1 0,-1 1 0,26 19 0,13 7 0,237 140 0,-254-150 0,-1 2 0,34 33 0,5 4 0,-18-16 0,-29-24 0,51 35 0,-14-15 0,-41-26 0,1-2 0,0-1 0,31 13 0,-21-12 0,1-2 0,1-2 0,0-1 0,1-3 0,0 0 0,0-3 0,44 2 0,-55-7 0,51 9 0,-49-5 0,46 2 0,39-5 0,266-5 0,-351 1 0,0-1 0,0-1 0,0-2 0,53-16 0,-70 17 0,0-1 0,-1 0 0,0-1 0,0-1 0,0 0 0,-1-1 0,-1 0 0,1 0 0,-1-2 0,-1 1 0,0-1 0,11-16 0,26-38 0,53-82 0,-87 125 0,-1-2 0,-1 0 0,-1 0 0,12-50 0,-12 19 0,-4-1 0,-1 1 0,-5-81 0,3-39 0,-1 164 0,0 0 0,1 0 0,0 0 0,1 1 0,0-1 0,0 1 0,10-15 0,-7 11 0,0 0 0,10-29 0,-6-11 0,-3 0 0,-1 0 0,-3 0 0,-5-80 0,1 77 0,-2 30 0,-1 1 0,-1 0 0,-14-46 0,-3-19 0,12 58 0,-1 1 0,-2 0 0,-1 1 0,-2 0 0,0 1 0,-21-28 0,-2-8 0,11 15 0,9 16 0,-1 0 0,-2 2 0,-47-60 0,52 77 0,1-2 0,1 0 0,1 0 0,1-1 0,0-1 0,1 0 0,-15-43 0,12 32 0,0 1 0,-3 0 0,0 1 0,-2 1 0,-1 1 0,-45-48 0,50 58 0,7 6 0,0 0 0,1-1 0,0 0 0,1 0 0,-7-20 0,7 16 0,-2 1 0,-14-26 0,-3 0 0,-35-80 0,38 74 0,-33-56 0,-15 6 0,-11-19 0,74 103 0,0-1 0,2 0 0,-6-19 0,7 18 0,-2 1 0,1-1 0,-9-13 0,-5 0 0,-2 1 0,-1 1 0,-1 1 0,-1 1 0,-1 1 0,-36-25 0,-55-53 0,52 41 0,-2 2 0,-3 4 0,-86-53 0,65 45 0,-117-105 0,179 139 0,1-1 0,2-1 0,-39-60 0,38 52 0,-1 1 0,-42-44 0,52 61 0,0-1 0,1-1 0,-24-42 0,25 36 0,-3 1 0,-22-27 0,-17-5 0,45 49 0,1-1 0,0 0 0,0-1 0,1 0 0,1 0 0,0-1 0,1-1 0,0 1 0,-6-17 0,-49-169 0,36 135 0,21 52 0,0 0 0,1-1 0,0 0 0,1 0 0,1 0 0,0-1 0,-1-13 0,3-263 0,3 134 0,-2 139 0,1 0 0,1 0 0,0 1 0,1-1 0,1 1 0,0-1 0,1 1 0,1 1 0,1-1 0,0 1 0,13-20 0,-8 18 0,0 1 0,2 0 0,0 1 0,0 0 0,2 2 0,-1-1 0,2 2 0,31-19 0,-38 25 0,-1 1 0,0-2 0,0 1 0,-1-1 0,1 0 0,-2-1 0,1 0 0,-1 0 0,0-1 0,-1 1 0,0-1 0,0-1 0,-1 1 0,0-1 0,5-16 0,3-1 0,1 0 0,1 0 0,20-24 0,-18 28 0,-2 0 0,-1-2 0,21-45 0,-25 42 0,2 1 0,0 0 0,2 0 0,2 1 0,0 1 0,1 1 0,40-44 0,-42 52 0,-1-1 0,-1-1 0,-1 0 0,0 0 0,-1-1 0,12-31 0,37-129 0,-26 68 0,57-186 0,-50 198 0,-21 55 0,15-49 0,-5-38 0,-12 45 0,5 12 0,-17 58 0,0-1 0,-1 0 0,-1 0 0,0 0 0,1-20 0,-4-240 0,-3 130 0,1 135 0,0-1 0,0 1 0,-2-1 0,1 1 0,-1 0 0,-1-1 0,-1 2 0,1-1 0,-9-14 0,-8-10 0,-40-50 0,40 59 0,1-2 0,-27-50 0,40 66 0,0 0 0,-1 0 0,-1 1 0,0 0 0,-1 1 0,0 0 0,-1 0 0,-18-14 0,10 11 0,-1 1 0,0 0 0,0 2 0,-40-16 0,41 20 0,-1 2 0,0 0 0,0 1 0,0 1 0,-22 0 0,-106 4 0,73 1 0,-30-3 0,-92 4 0,167 2 0,0 1 0,1 1 0,-1 2 0,1 1 0,-52 26 0,38-17 0,-61 19 0,59-27 0,0-2 0,-88 7 0,-95-13 0,144-4 0,47 3 0,-49 9 0,47-6 0,-42 2 0,-22-5 0,-442-5 0,522-1 0,0 0 0,1-1 0,0-1 0,0-2 0,0 0 0,1-1 0,-35-21 0,-43-17 0,-104-24 0,171 63 0,0 1 0,-1 1 0,0 2 0,-52 1 0,38 4 0,17 1 0,0-2 0,-59-7 0,80 6 0,-1-1 0,1-1 0,-1 0 0,1 0 0,0-1 0,1 0 0,-1-1 0,1 1 0,-1-2 0,1 1 0,1-1 0,-1 0 0,-8-11 0,-4-9 0,1-1 0,1-1 0,2 0 0,1-2 0,1 1 0,-11-36 0,18 45 0,3 6 0,-1 0 0,0 1 0,-1-1 0,0 1 0,-1 0 0,-1 1 0,0-1 0,0 1 0,-1 1 0,-1 0 0,0 0 0,-12-9 0,-231-154 0,243 168 0,-1 1 0,0 1 0,0 0 0,-1 1 0,1 0 0,-1 0 0,0 1 0,-15 0 0,-102 3 0,68 1 0,-98-2 0,-104 2 0,222 2 0,0 1 0,0 2 0,1 2 0,-50 17 0,-154 71 0,174-67 0,45-18 0,0 2 0,1 1 0,1 0 0,-27 24 0,20-15 0,-47 28 0,60-44 0,1-1 0,-2-1 0,1 0 0,-1-1 0,-18 2 0,13-2 0,0 1 0,-32 12 0,43-14 0,0 0 0,0-1 0,0 0 0,-15 0 0,16-2 0,0 1 0,0 0 0,0 1 0,-19 7 0,26-8 0,1 0 0,-1 0 0,1 0 0,0 0 0,0 1 0,0-1 0,0 1 0,0 0 0,0 0 0,1 0 0,-1 0 0,1 1 0,0-1 0,0 1 0,1-1 0,-1 1 0,-2 7 0,-28 121 0,10-31 0,15-83-227,0-1-1,-1 1 1,-1-1-1,-1-1 1,-14 21-1,13-23-6598</inkml:trace>
-</inkml:ink>
-</file>
-
-<file path=ppt/ink/ink2.xml><?xml version="1.0" encoding="utf-8"?>
 <inkml:ink xmlns:inkml="http://www.w3.org/2003/InkML">
   <inkml:definitions>
     <inkml:context xml:id="ctx0">
@@ -3725,57 +3697,6 @@
           </a:p>
         </p:txBody>
       </p:sp>
-      <mc:AlternateContent xmlns:mc="http://schemas.openxmlformats.org/markup-compatibility/2006">
-        <mc:Choice xmlns:p14="http://schemas.microsoft.com/office/powerpoint/2010/main" Requires="p14">
-          <p:contentPart p14:bwMode="auto" r:id="rId3">
-            <p14:nvContentPartPr>
-              <p14:cNvPr id="8" name="Ink 7">
-                <a:extLst>
-                  <a:ext uri="{FF2B5EF4-FFF2-40B4-BE49-F238E27FC236}">
-                    <a16:creationId xmlns:a16="http://schemas.microsoft.com/office/drawing/2014/main" id="{4DDFF287-9472-81AA-7782-D707DE9F6FD3}"/>
-                  </a:ext>
-                </a:extLst>
-              </p14:cNvPr>
-              <p14:cNvContentPartPr/>
-              <p14:nvPr/>
-            </p14:nvContentPartPr>
-            <p14:xfrm>
-              <a:off x="4292691" y="2323286"/>
-              <a:ext cx="2970720" cy="3704040"/>
-            </p14:xfrm>
-          </p:contentPart>
-        </mc:Choice>
-        <mc:Fallback>
-          <p:pic>
-            <p:nvPicPr>
-              <p:cNvPr id="8" name="Ink 7">
-                <a:extLst>
-                  <a:ext uri="{FF2B5EF4-FFF2-40B4-BE49-F238E27FC236}">
-                    <a16:creationId xmlns:a16="http://schemas.microsoft.com/office/drawing/2014/main" id="{4DDFF287-9472-81AA-7782-D707DE9F6FD3}"/>
-                  </a:ext>
-                </a:extLst>
-              </p:cNvPr>
-              <p:cNvPicPr/>
-              <p:nvPr/>
-            </p:nvPicPr>
-            <p:blipFill>
-              <a:blip r:embed="rId4"/>
-              <a:stretch>
-                <a:fillRect/>
-              </a:stretch>
-            </p:blipFill>
-            <p:spPr>
-              <a:xfrm>
-                <a:off x="4286571" y="2317166"/>
-                <a:ext cx="2982960" cy="3716280"/>
-              </a:xfrm>
-              <a:prstGeom prst="rect">
-                <a:avLst/>
-              </a:prstGeom>
-            </p:spPr>
-          </p:pic>
-        </mc:Fallback>
-      </mc:AlternateContent>
     </p:spTree>
   </p:cSld>
   <p:clrMapOvr>
@@ -3926,8 +3847,8 @@
           </a:p>
         </p:txBody>
       </p:sp>
-      <mc:AlternateContent xmlns:mc="http://schemas.openxmlformats.org/markup-compatibility/2006">
-        <mc:Choice xmlns:p14="http://schemas.microsoft.com/office/powerpoint/2010/main" Requires="p14">
+      <mc:AlternateContent xmlns:mc="http://schemas.openxmlformats.org/markup-compatibility/2006" xmlns:p14="http://schemas.microsoft.com/office/powerpoint/2010/main">
+        <mc:Choice Requires="p14">
           <p:contentPart p14:bwMode="auto" r:id="rId3">
             <p14:nvContentPartPr>
               <p14:cNvPr id="4" name="Ink 3">
@@ -3946,7 +3867,7 @@
             </p14:xfrm>
           </p:contentPart>
         </mc:Choice>
-        <mc:Fallback>
+        <mc:Fallback xmlns="">
           <p:pic>
             <p:nvPicPr>
               <p:cNvPr id="4" name="Ink 3">

</xml_diff>